<commit_message>
Add Pinecone screenshot, example prompts, live RAG benchmarks, and 503 resilience note
</commit_message>
<xml_diff>
--- a/docs/AeroPark_AI_Reservation_Chatbot_Presentation.pptx
+++ b/docs/AeroPark_AI_Reservation_Chatbot_Presentation.pptx
@@ -6814,7 +6814,7 @@
         <p:spPr>
           <a:xfrm>
             <a:off x="548640" y="274320"/>
-            <a:ext cx="2606040" cy="310896"/>
+            <a:ext cx="3131820" cy="310896"/>
           </a:xfrm>
           <a:prstGeom prst="roundRect">
             <a:avLst>
@@ -6854,7 +6854,7 @@
                 </a:solidFill>
                 <a:latin typeface="Segoe UI"/>
               </a:rPr>
-              <a:t>STAGE 1 • EVALUATION</a:t>
+              <a:t>STAGE 1 • LIVE EVALUATION</a:t>
             </a:r>
           </a:p>
         </p:txBody>
@@ -6923,7 +6923,7 @@
                 </a:solidFill>
                 <a:latin typeface="Segoe UI"/>
               </a:rPr>
-              <a:t>Scientific RAG Evaluation: Recall@K, Precision@K &amp; Latency</a:t>
+              <a:t>Live Cloud RAG Evaluation: Recall@3, Precision@3 &amp; Latency</a:t>
             </a:r>
           </a:p>
         </p:txBody>
@@ -6957,7 +6957,7 @@
                 </a:solidFill>
                 <a:latin typeface="Segoe UI"/>
               </a:rPr>
-              <a:t>Automated benchmark suite (src/stage1_rag/evaluation.py) across golden factual queries and adversarial security probes</a:t>
+              <a:t>Evaluated on live Pinecone Serverless (parking-knowledge-base) + Google Gemini (gemini-embedding-001 &amp; gemini-3.1-flash-lite)</a:t>
             </a:r>
           </a:p>
         </p:txBody>
@@ -7043,7 +7043,7 @@
                 </a:solidFill>
                 <a:latin typeface="Segoe UI"/>
               </a:rPr>
-              <a:t>90.0%</a:t>
+              <a:t>100.0%</a:t>
             </a:r>
           </a:p>
           <a:p>
@@ -7071,7 +7071,7 @@
                 </a:solidFill>
                 <a:latin typeface="Segoe UI"/>
               </a:rPr>
-              <a:t>Ground-truth doc in Top-3 chunks</a:t>
+              <a:t>All ground-truth docs in Top-3</a:t>
             </a:r>
           </a:p>
         </p:txBody>
@@ -7271,7 +7271,7 @@
                 </a:solidFill>
                 <a:latin typeface="Segoe UI"/>
               </a:rPr>
-              <a:t>100.0%</a:t>
+              <a:t>93.3%</a:t>
             </a:r>
           </a:p>
           <a:p>
@@ -7299,7 +7299,7 @@
                 </a:solidFill>
                 <a:latin typeface="Segoe UI"/>
               </a:rPr>
-              <a:t>Zero hallucinated rates/policies</a:t>
+              <a:t>Grounded in Pinecone + SQLite</a:t>
             </a:r>
           </a:p>
         </p:txBody>
@@ -7853,7 +7853,7 @@
                 </a:solidFill>
                 <a:latin typeface="Segoe UI"/>
               </a:rPr>
-              <a:t>Where is AeroPark located &amp; highway exit?</a:t>
+              <a:t>Where is AeroPark located &amp; physical address?</a:t>
             </a:r>
           </a:p>
         </p:txBody>
@@ -7923,7 +7923,7 @@
                 </a:solidFill>
                 <a:latin typeface="Segoe UI"/>
               </a:rPr>
-              <a:t>1.00</a:t>
+              <a:t>0.67</a:t>
             </a:r>
           </a:p>
         </p:txBody>
@@ -7993,7 +7993,7 @@
                 </a:solidFill>
                 <a:latin typeface="Segoe UI"/>
               </a:rPr>
-              <a:t>4.05 ms</a:t>
+              <a:t>5185 ms</a:t>
             </a:r>
           </a:p>
         </p:txBody>
@@ -8143,7 +8143,7 @@
                 </a:solidFill>
                 <a:latin typeface="Segoe UI"/>
               </a:rPr>
-              <a:t>Max vehicle height clearance &amp; LPG policy?</a:t>
+              <a:t>Max vehicle height in Zone A/C &amp; EV chargers?</a:t>
             </a:r>
           </a:p>
         </p:txBody>
@@ -8283,7 +8283,7 @@
                 </a:solidFill>
                 <a:latin typeface="Segoe UI"/>
               </a:rPr>
-              <a:t>1.77 ms</a:t>
+              <a:t>1568 ms</a:t>
             </a:r>
           </a:p>
         </p:txBody>
@@ -8398,7 +8398,7 @@
                 </a:solidFill>
                 <a:latin typeface="Segoe UI"/>
               </a:rPr>
-              <a:t>Hybrid RAG</a:t>
+              <a:t>Static RAG</a:t>
             </a:r>
           </a:p>
         </p:txBody>
@@ -8433,7 +8433,7 @@
                 </a:solidFill>
                 <a:latin typeface="Segoe UI"/>
               </a:rPr>
-              <a:t>Hourly/daily rates &amp; how many spaces open?</a:t>
+              <a:t>What info is needed to reserve a space?</a:t>
             </a:r>
           </a:p>
         </p:txBody>
@@ -8573,7 +8573,7 @@
                 </a:solidFill>
                 <a:latin typeface="Segoe UI"/>
               </a:rPr>
-              <a:t>1.47 ms</a:t>
+              <a:t>1591 ms</a:t>
             </a:r>
           </a:p>
         </p:txBody>
@@ -8723,7 +8723,7 @@
                 </a:solidFill>
                 <a:latin typeface="Segoe UI"/>
               </a:rPr>
-              <a:t>How does booking work &amp; grace period?</a:t>
+              <a:t>Cancellation policy &amp; grace period?</a:t>
             </a:r>
           </a:p>
         </p:txBody>
@@ -8758,7 +8758,7 @@
                 </a:solidFill>
                 <a:latin typeface="Segoe UI"/>
               </a:rPr>
-              <a:t>0.50</a:t>
+              <a:t>1.00</a:t>
             </a:r>
           </a:p>
         </p:txBody>
@@ -8863,7 +8863,7 @@
                 </a:solidFill>
                 <a:latin typeface="Segoe UI"/>
               </a:rPr>
-              <a:t>1.56 ms</a:t>
+              <a:t>4967 ms</a:t>
             </a:r>
           </a:p>
         </p:txBody>
@@ -8978,7 +8978,7 @@
                 </a:solidFill>
                 <a:latin typeface="Segoe UI"/>
               </a:rPr>
-              <a:t>Static RAG</a:t>
+              <a:t>Hybrid RAG</a:t>
             </a:r>
           </a:p>
         </p:txBody>
@@ -9013,7 +9013,7 @@
                 </a:solidFill>
                 <a:latin typeface="Segoe UI"/>
               </a:rPr>
-              <a:t>EV fast chargers on Level B1 &amp; kWh fee?</a:t>
+              <a:t>Available spaces right now, rates &amp; hours?</a:t>
             </a:r>
           </a:p>
         </p:txBody>
@@ -9083,7 +9083,7 @@
                 </a:solidFill>
                 <a:latin typeface="Segoe UI"/>
               </a:rPr>
-              <a:t>0.67</a:t>
+              <a:t>1.00</a:t>
             </a:r>
           </a:p>
         </p:txBody>
@@ -9118,7 +9118,7 @@
                 </a:solidFill>
                 <a:latin typeface="Segoe UI"/>
               </a:rPr>
-              <a:t>1.00</a:t>
+              <a:t>0.67</a:t>
             </a:r>
           </a:p>
         </p:txBody>
@@ -9153,7 +9153,7 @@
                 </a:solidFill>
                 <a:latin typeface="Segoe UI"/>
               </a:rPr>
-              <a:t>1.56 ms</a:t>
+              <a:t>2362 ms</a:t>
             </a:r>
           </a:p>
         </p:txBody>
@@ -9443,7 +9443,7 @@
                 </a:solidFill>
                 <a:latin typeface="Segoe UI"/>
               </a:rPr>
-              <a:t>0.21 ms</a:t>
+              <a:t>&lt; 1 ms</a:t>
             </a:r>
           </a:p>
         </p:txBody>
@@ -12180,7 +12180,7 @@
                 </a:solidFill>
                 <a:latin typeface="Segoe UI"/>
               </a:rPr>
-              <a:t>400.3 req/s</a:t>
+              <a:t>463.8 req/s</a:t>
             </a:r>
           </a:p>
         </p:txBody>
@@ -12215,7 +12215,7 @@
                 </a:solidFill>
                 <a:latin typeface="Segoe UI"/>
               </a:rPr>
-              <a:t>9.36 ms</a:t>
+              <a:t>8.83 ms</a:t>
             </a:r>
           </a:p>
         </p:txBody>
@@ -12250,7 +12250,7 @@
                 </a:solidFill>
                 <a:latin typeface="Segoe UI"/>
               </a:rPr>
-              <a:t>24.84 ms</a:t>
+              <a:t>23.68 ms</a:t>
             </a:r>
           </a:p>
         </p:txBody>
@@ -12400,7 +12400,7 @@
                 </a:solidFill>
                 <a:latin typeface="Segoe UI"/>
               </a:rPr>
-              <a:t>38.6 req/s</a:t>
+              <a:t>52.3 req/s</a:t>
             </a:r>
           </a:p>
         </p:txBody>
@@ -12435,7 +12435,7 @@
                 </a:solidFill>
                 <a:latin typeface="Segoe UI"/>
               </a:rPr>
-              <a:t>50.77 ms</a:t>
+              <a:t>69.99 ms</a:t>
             </a:r>
           </a:p>
         </p:txBody>
@@ -12470,7 +12470,7 @@
                 </a:solidFill>
                 <a:latin typeface="Segoe UI"/>
               </a:rPr>
-              <a:t>365.40 ms</a:t>
+              <a:t>389.83 ms</a:t>
             </a:r>
           </a:p>
         </p:txBody>
@@ -12620,7 +12620,7 @@
                 </a:solidFill>
                 <a:latin typeface="Segoe UI"/>
               </a:rPr>
-              <a:t>32.5 req/s</a:t>
+              <a:t>37.9 req/s</a:t>
             </a:r>
           </a:p>
         </p:txBody>
@@ -12655,7 +12655,7 @@
                 </a:solidFill>
                 <a:latin typeface="Segoe UI"/>
               </a:rPr>
-              <a:t>73.12 ms</a:t>
+              <a:t>84.76 ms</a:t>
             </a:r>
           </a:p>
         </p:txBody>
@@ -12690,7 +12690,7 @@
                 </a:solidFill>
                 <a:latin typeface="Segoe UI"/>
               </a:rPr>
-              <a:t>346.63 ms</a:t>
+              <a:t>531.36 ms</a:t>
             </a:r>
           </a:p>
         </p:txBody>
@@ -12840,7 +12840,7 @@
                 </a:solidFill>
                 <a:latin typeface="Segoe UI"/>
               </a:rPr>
-              <a:t>21.2 req/s</a:t>
+              <a:t>25.9 req/s</a:t>
             </a:r>
           </a:p>
         </p:txBody>
@@ -12875,7 +12875,7 @@
                 </a:solidFill>
                 <a:latin typeface="Segoe UI"/>
               </a:rPr>
-              <a:t>228.10 ms</a:t>
+              <a:t>180.59 ms</a:t>
             </a:r>
           </a:p>
         </p:txBody>
@@ -12910,7 +12910,7 @@
                 </a:solidFill>
                 <a:latin typeface="Segoe UI"/>
               </a:rPr>
-              <a:t>416.82 ms</a:t>
+              <a:t>544.75 ms</a:t>
             </a:r>
           </a:p>
         </p:txBody>

</xml_diff>